<commit_message>
Presentación: E7 con el incidente del cruce corregido
Diapositiva 12 y guion: cifras del cruce con incidente en la aproximación sur (los
aprendidos mejoran 16 % al fijo y quedan 21 % por detrás de max-pressure). PPTX, gemelo
HTML y PDF regenerados.

Co-Authored-By: Claude Opus 5.5 <noreply@anthropic.com>
</commit_message>
<xml_diff>
--- a/docs/slides/presentacion.pptx
+++ b/docs/slides/presentacion.pptx
@@ -125,14 +125,14 @@
   <p:extLst>
     <p:ext uri="{521415D9-36F7-43E2-AB2F-B90AF26B5E84}">
       <p14:sectionLst xmlns:p14="http://schemas.microsoft.com/office/powerpoint/2010/main">
-        <p14:section name="Introducción" id="{fa4aa2ac-9d71-143b-1d7a-4638299fb4bd}">
+        <p14:section name="Introducción" id="{ae023e82-eff6-2394-7015-9799cb245e30}">
           <p14:sldIdLst>
             <p14:sldId id="256"/>
             <p14:sldId id="257"/>
             <p14:sldId id="258"/>
           </p14:sldIdLst>
         </p14:section>
-        <p14:section name="Modelo y métodos" id="{8ec1ec7f-072f-fd03-8691-dc03586c5d46}">
+        <p14:section name="Modelo y métodos" id="{a0b26748-0ce8-26b1-3018-88290726708b}">
           <p14:sldIdLst>
             <p14:sldId id="259"/>
             <p14:sldId id="260"/>
@@ -141,7 +141,7 @@
             <p14:sldId id="263"/>
           </p14:sldIdLst>
         </p14:section>
-        <p14:section name="Resultados" id="{502ca9da-4809-850f-7a79-916fab0c889f}">
+        <p14:section name="Resultados" id="{3a6f4376-0bb3-4cc0-e703-e1669c9be8af}">
           <p14:sldIdLst>
             <p14:sldId id="264"/>
             <p14:sldId id="265"/>
@@ -151,7 +151,7 @@
             <p14:sldId id="269"/>
           </p14:sldIdLst>
         </p14:section>
-        <p14:section name="Demo y cierre" id="{c190e110-389b-fa6b-7933-44f9da183582}">
+        <p14:section name="Demo y cierre" id="{dae13c16-0be2-fe63-50ca-acf903534721}">
           <p14:sldIdLst>
             <p14:sldId id="270"/>
             <p14:sldId id="271"/>
@@ -2096,7 +2096,7 @@
           <a:p>
             <a:r>
               <a:rPr lang="en-US" dirty="0"/>
-              <a:t>E7 pregunta si el mejor agente generaliza. A mediodía, una hora que no vio, todos los agentes siguen ganándole al tiempo fijo, y MAPPO tiene la menor demora del corredor. Con el carril cerrado, MAPPO y comunicación mejoran al fijo y al actuado, pero no a max-pressure. La caída está con 30 % más demanda: MAPPO sube a 373 segundos, 8 % peor que el tiempo fijo y 48 % peor que max-pressure, y deja casi un cuarto de la demanda sin entrar. Con las cinco semillas de E5 el resultado es el mismo. Su demora se multiplica por 10 respecto de la hora pico, contra 6 de max-pressure. Ojo: aquí cada agente es una sola semilla, la mejor en validación, así que la tabla incluso favorece a los agentes. Lo aprendido no se sostiene fuera del rango de demanda del entrenamiento.</a:t>
+              <a:t>E7 pregunta si el mejor agente generaliza. A mediodía, una hora que no vio, todos los agentes siguen ganándole al tiempo fijo, y MAPPO tiene la menor demora del corredor. Con el carril cerrado, MAPPO y comunicación mejoran al fijo y al actuado, pero no a max-pressure. En el cruce aislado, con dos carriles cerrados en la aproximación sur, DQN y PPO mejoran 16 % al tiempo fijo pero quedan 21 % por detrás de max-pressure. La caída está con 30 % más demanda: MAPPO sube a 373 segundos, 8 % peor que el tiempo fijo y 48 % peor que max-pressure, y deja casi un cuarto de la demanda sin entrar. Con las cinco semillas de E5 el resultado es el mismo. Su demora se multiplica por 10 respecto de la hora pico, contra 6 de max-pressure. Ojo: aquí cada agente es una sola semilla, la mejor en validación, así que la tabla incluso favorece a los agentes. Lo aprendido no se sostiene fuera del rango de demanda del entrenamiento.</a:t>
             </a:r>
             <a:endParaRPr lang="en-US" dirty="0"/>
           </a:p>
@@ -7509,7 +7509,43 @@
       </p:sp>
       <p:sp>
         <p:nvSpPr>
-          <p:cNvPr id="5" name="tarjeta x13"/>
+          <p:cNvPr id="5" name="nota al pie"/>
+          <p:cNvSpPr txBox="1"/>
+          <p:nvPr/>
+        </p:nvSpPr>
+        <p:spPr>
+          <a:xfrm>
+            <a:off x="548640" y="5532120"/>
+            <a:ext cx="7040880" cy="320040"/>
+          </a:xfrm>
+          <a:prstGeom prst="rect">
+            <a:avLst/>
+          </a:prstGeom>
+          <a:noFill/>
+          <a:ln/>
+        </p:spPr>
+        <p:txBody>
+          <a:bodyPr wrap="square" lIns="0" tIns="0" rIns="0" bIns="0" rtlCol="0" anchor="ctr"/>
+          <a:lstStyle/>
+          <a:p>
+            <a:pPr indent="0" marL="0">
+              <a:buNone/>
+            </a:pPr>
+            <a:r>
+              <a:rPr lang="en-US" sz="1100" i="1" dirty="0">
+                <a:solidFill>
+                  <a:schemeClr val="bg2"/>
+                </a:solidFill>
+              </a:rPr>
+              <a:t>Cruce C12 con incidente (2 de 3 carriles de la aproximación sur cerrados): max-pressure 158, DQN 190, PPO 192, actuado 201, fijo 228 s/veh.</a:t>
+            </a:r>
+            <a:endParaRPr lang="en-US" sz="1100" dirty="0"/>
+          </a:p>
+        </p:txBody>
+      </p:sp>
+      <p:sp>
+        <p:nvSpPr>
+          <p:cNvPr id="6" name="tarjeta x13"/>
           <p:cNvSpPr/>
           <p:nvPr/>
         </p:nvSpPr>
@@ -7536,7 +7572,7 @@
       </p:sp>
       <p:sp>
         <p:nvSpPr>
-          <p:cNvPr id="6" name="cifra x13"/>
+          <p:cNvPr id="7" name="cifra x13"/>
           <p:cNvSpPr txBox="1"/>
           <p:nvPr/>
         </p:nvSpPr>
@@ -7572,7 +7608,7 @@
       </p:sp>
       <p:sp>
         <p:nvSpPr>
-          <p:cNvPr id="7" name="etiqueta x13"/>
+          <p:cNvPr id="8" name="etiqueta x13"/>
           <p:cNvSpPr txBox="1"/>
           <p:nvPr/>
         </p:nvSpPr>
@@ -7611,7 +7647,7 @@
       </p:sp>
       <p:sp>
         <p:nvSpPr>
-          <p:cNvPr id="8" name="tarjeta degradacion"/>
+          <p:cNvPr id="9" name="tarjeta degradacion"/>
           <p:cNvSpPr/>
           <p:nvPr/>
         </p:nvSpPr>
@@ -7638,7 +7674,7 @@
       </p:sp>
       <p:sp>
         <p:nvSpPr>
-          <p:cNvPr id="9" name="cifra degradacion"/>
+          <p:cNvPr id="10" name="cifra degradacion"/>
           <p:cNvSpPr txBox="1"/>
           <p:nvPr/>
         </p:nvSpPr>
@@ -7674,7 +7710,7 @@
       </p:sp>
       <p:sp>
         <p:nvSpPr>
-          <p:cNvPr id="10" name="etiqueta degradacion"/>
+          <p:cNvPr id="11" name="etiqueta degradacion"/>
           <p:cNvSpPr txBox="1"/>
           <p:nvPr/>
         </p:nvSpPr>

</xml_diff>

<commit_message>
Video de respaldo regrabado con el mapa nuevo (4:06, 8 capítulos) y slides al día
- record_demo.py: coreografía para el mapa nuevo (Vista, conos del incidente, noche) y registro de eventos.
- HyperFrames: EDL por cuadros enteros, capítulo 02 «La calle de cerca», anillos y punch-ins
  para los mapas apilados, cama de música de 246 s (misma pista de HeyGen).
- Slides: captura nueva de la demo, mapas arriba/abajo, plan B de 4:06; pptx regenerado con el tema original.

Co-Authored-By: Claude Opus 5.5 <noreply@anthropic.com>
</commit_message>
<xml_diff>
--- a/docs/slides/presentacion.pptx
+++ b/docs/slides/presentacion.pptx
@@ -125,14 +125,14 @@
   <p:extLst>
     <p:ext uri="{521415D9-36F7-43E2-AB2F-B90AF26B5E84}">
       <p14:sectionLst xmlns:p14="http://schemas.microsoft.com/office/powerpoint/2010/main">
-        <p14:section name="Introducción" id="{ae023e82-eff6-2394-7015-9799cb245e30}">
+        <p14:section name="Introducción" id="{7bfa237b-7cf8-40b8-155d-dabf40af92df}">
           <p14:sldIdLst>
             <p14:sldId id="256"/>
             <p14:sldId id="257"/>
             <p14:sldId id="258"/>
           </p14:sldIdLst>
         </p14:section>
-        <p14:section name="Modelo y métodos" id="{a0b26748-0ce8-26b1-3018-88290726708b}">
+        <p14:section name="Modelo y métodos" id="{ac1a490f-4f50-a503-79d2-cf8008a596cc}">
           <p14:sldIdLst>
             <p14:sldId id="259"/>
             <p14:sldId id="260"/>
@@ -141,7 +141,7 @@
             <p14:sldId id="263"/>
           </p14:sldIdLst>
         </p14:section>
-        <p14:section name="Resultados" id="{3a6f4376-0bb3-4cc0-e703-e1669c9be8af}">
+        <p14:section name="Resultados" id="{31330f5b-5f7f-86fc-c477-7bc9072f5c5a}">
           <p14:sldIdLst>
             <p14:sldId id="264"/>
             <p14:sldId id="265"/>
@@ -151,7 +151,7 @@
             <p14:sldId id="269"/>
           </p14:sldIdLst>
         </p14:section>
-        <p14:section name="Demo y cierre" id="{dae13c16-0be2-fe63-50ca-acf903534721}">
+        <p14:section name="Demo y cierre" id="{e24f7a30-60dc-7088-273a-62d51d87b36a}">
           <p14:sldIdLst>
             <p14:sldId id="270"/>
             <p14:sldId id="271"/>
@@ -2360,7 +2360,7 @@
           <a:p>
             <a:r>
               <a:rPr lang="en-US" dirty="0"/>
-              <a:t>Ahora la demo. Son dos simulaciones de SUMO corriendo en paralelo con la misma demanda y la misma semilla: a la izquierda el semáforo de tiempo fijo y a la derecha MAPPO, el modelo entrenado real. Vamos a: uno, arrancar en hora pico y acelerar para ver cómo se separan las curvas; dos, inyectar carros en la entrada sur y en la 12 calle; tres, cerrar dos carriles entre la 12 y la 10a calle y ver cómo crece la cola. Una aclaración: la tarjeta «Mejora» usa la espera promedio en vivo, que no es la demora total de la evaluación; los números oficiales son los que ya mostramos. Si algo falla, tenemos el video de respaldo de tres minutos y medio.</a:t>
+              <a:t>Ahora la demo. Son dos simulaciones de SUMO corriendo en paralelo con la misma demanda y la misma semilla: arriba el semáforo de tiempo fijo y abajo MAPPO, el modelo entrenado real. Vamos a: uno, arrancar en hora pico y acelerar para ver cómo se separan las curvas; dos, inyectar carros en la entrada sur y en la 12 calle; tres, cerrar dos carriles entre la 12 y la 10a calle y ver cómo crece la cola. Una aclaración: la tarjeta «Mejora» usa la espera promedio en vivo, que no es la demora total de la evaluación; los números oficiales son los que ya mostramos. Si algo falla, tenemos el video de respaldo de unos cuatro minutos.</a:t>
             </a:r>
             <a:endParaRPr lang="en-US" dirty="0"/>
           </a:p>
@@ -8701,7 +8701,7 @@
                   <a:schemeClr val="accent2"/>
                 </a:solidFill>
               </a:rPr>
-              <a:t>Plan B: video de 3:46</a:t>
+              <a:t>Plan B: video de 4:06</a:t>
             </a:r>
             <a:endParaRPr lang="en-US" sz="1600" dirty="0"/>
           </a:p>

</xml_diff>